<commit_message>
Remove speaker notes from 2026 performance deck
Co-Authored-By: Claude Opus 5.5 <noreply@anthropic.com>
Claude-Session: https://claude.ai/code/session_015KGeERGX8tZXyoMsdSGKK4
</commit_message>
<xml_diff>
--- a/2026_Performance_updated_3.pptx
+++ b/2026_Performance_updated_3.pptx
@@ -267,1056 +267,6 @@
     </a:lvl9pPr>
   </p:notesStyle>
 </p:notesMaster>
-</file>
-
-<file path=ppt/notesSlides/notesSlide1.xml><?xml version="1.0" encoding="utf-8"?>
-<p:notes xmlns:a="http://schemas.openxmlformats.org/drawingml/2006/main" xmlns:r="http://schemas.openxmlformats.org/officeDocument/2006/relationships" xmlns:p="http://schemas.openxmlformats.org/presentationml/2006/main">
-  <p:cSld>
-    <p:spTree>
-      <p:nvGrpSpPr>
-        <p:cNvPr id="1" name=""/>
-        <p:cNvGrpSpPr/>
-        <p:nvPr/>
-      </p:nvGrpSpPr>
-      <p:grpSpPr>
-        <a:xfrm>
-          <a:off x="0" y="0"/>
-          <a:ext cx="0" cy="0"/>
-          <a:chOff x="0" y="0"/>
-          <a:chExt cx="0" cy="0"/>
-        </a:xfrm>
-      </p:grpSpPr>
-      <p:sp>
-        <p:nvSpPr>
-          <p:cNvPr id="2" name="Slide Image Placeholder 1"/>
-          <p:cNvSpPr>
-            <a:spLocks noGrp="1" noRot="1" noChangeAspect="1"/>
-          </p:cNvSpPr>
-          <p:nvPr>
-            <p:ph type="sldImg" idx="2"/>
-          </p:nvPr>
-        </p:nvSpPr>
-        <p:spPr/>
-      </p:sp>
-      <p:sp>
-        <p:nvSpPr>
-          <p:cNvPr id="3" name="Notes Placeholder 2"/>
-          <p:cNvSpPr>
-            <a:spLocks noGrp="1"/>
-          </p:cNvSpPr>
-          <p:nvPr>
-            <p:ph type="body" sz="quarter" idx="3"/>
-          </p:nvPr>
-        </p:nvSpPr>
-        <p:spPr/>
-        <p:txBody>
-          <a:bodyPr/>
-          <a:lstStyle/>
-          <a:p>
-            <a:r>
-              <a:t>Coastal Air Plus marketing performance from January 1 through October 23, 2026. Digital figures come directly from Searchlight's performance-by report export.</a:t>
-            </a:r>
-          </a:p>
-        </p:txBody>
-      </p:sp>
-      <p:sp>
-        <p:nvSpPr>
-          <p:cNvPr id="4" name="Slide Number Placeholder 3"/>
-          <p:cNvSpPr>
-            <a:spLocks noGrp="1"/>
-          </p:cNvSpPr>
-          <p:nvPr>
-            <p:ph type="sldNum" sz="quarter" idx="5"/>
-          </p:nvPr>
-        </p:nvSpPr>
-        <p:spPr/>
-      </p:sp>
-    </p:spTree>
-  </p:cSld>
-  <p:clrMapOvr>
-    <a:masterClrMapping/>
-  </p:clrMapOvr>
-</p:notes>
-</file>
-
-<file path=ppt/notesSlides/notesSlide10.xml><?xml version="1.0" encoding="utf-8"?>
-<p:notes xmlns:a="http://schemas.openxmlformats.org/drawingml/2006/main" xmlns:r="http://schemas.openxmlformats.org/officeDocument/2006/relationships" xmlns:p="http://schemas.openxmlformats.org/presentationml/2006/main">
-  <p:cSld>
-    <p:spTree>
-      <p:nvGrpSpPr>
-        <p:cNvPr id="1" name=""/>
-        <p:cNvGrpSpPr/>
-        <p:nvPr/>
-      </p:nvGrpSpPr>
-      <p:grpSpPr>
-        <a:xfrm>
-          <a:off x="0" y="0"/>
-          <a:ext cx="0" cy="0"/>
-          <a:chOff x="0" y="0"/>
-          <a:chExt cx="0" cy="0"/>
-        </a:xfrm>
-      </p:grpSpPr>
-      <p:sp>
-        <p:nvSpPr>
-          <p:cNvPr id="2" name="Slide Image Placeholder 1"/>
-          <p:cNvSpPr>
-            <a:spLocks noGrp="1" noRot="1" noChangeAspect="1"/>
-          </p:cNvSpPr>
-          <p:nvPr>
-            <p:ph type="sldImg" idx="2"/>
-          </p:nvPr>
-        </p:nvSpPr>
-        <p:spPr/>
-      </p:sp>
-      <p:sp>
-        <p:nvSpPr>
-          <p:cNvPr id="3" name="Notes Placeholder 2"/>
-          <p:cNvSpPr>
-            <a:spLocks noGrp="1"/>
-          </p:cNvSpPr>
-          <p:nvPr>
-            <p:ph type="body" sz="quarter" idx="3"/>
-          </p:nvPr>
-        </p:nvSpPr>
-        <p:spPr/>
-        <p:txBody>
-          <a:bodyPr/>
-          <a:lstStyle/>
-          <a:p>
-            <a:r>
-              <a:t>These paid campaigns closed less revenue than they cost. The Myrtle Beach non-brand HVAC and plumbing search campaigns are the largest. Recent offer campaigns may still close revenue.</a:t>
-            </a:r>
-          </a:p>
-        </p:txBody>
-      </p:sp>
-      <p:sp>
-        <p:nvSpPr>
-          <p:cNvPr id="4" name="Slide Number Placeholder 3"/>
-          <p:cNvSpPr>
-            <a:spLocks noGrp="1"/>
-          </p:cNvSpPr>
-          <p:nvPr>
-            <p:ph type="sldNum" sz="quarter" idx="5"/>
-          </p:nvPr>
-        </p:nvSpPr>
-        <p:spPr/>
-      </p:sp>
-    </p:spTree>
-  </p:cSld>
-  <p:clrMapOvr>
-    <a:masterClrMapping/>
-  </p:clrMapOvr>
-</p:notes>
-</file>
-
-<file path=ppt/notesSlides/notesSlide11.xml><?xml version="1.0" encoding="utf-8"?>
-<p:notes xmlns:a="http://schemas.openxmlformats.org/drawingml/2006/main" xmlns:r="http://schemas.openxmlformats.org/officeDocument/2006/relationships" xmlns:p="http://schemas.openxmlformats.org/presentationml/2006/main">
-  <p:cSld>
-    <p:spTree>
-      <p:nvGrpSpPr>
-        <p:cNvPr id="1" name=""/>
-        <p:cNvGrpSpPr/>
-        <p:nvPr/>
-      </p:nvGrpSpPr>
-      <p:grpSpPr>
-        <a:xfrm>
-          <a:off x="0" y="0"/>
-          <a:ext cx="0" cy="0"/>
-          <a:chOff x="0" y="0"/>
-          <a:chExt cx="0" cy="0"/>
-        </a:xfrm>
-      </p:grpSpPr>
-      <p:sp>
-        <p:nvSpPr>
-          <p:cNvPr id="2" name="Slide Image Placeholder 1"/>
-          <p:cNvSpPr>
-            <a:spLocks noGrp="1" noRot="1" noChangeAspect="1"/>
-          </p:cNvSpPr>
-          <p:nvPr>
-            <p:ph type="sldImg" idx="2"/>
-          </p:nvPr>
-        </p:nvSpPr>
-        <p:spPr/>
-      </p:sp>
-      <p:sp>
-        <p:nvSpPr>
-          <p:cNvPr id="3" name="Notes Placeholder 2"/>
-          <p:cNvSpPr>
-            <a:spLocks noGrp="1"/>
-          </p:cNvSpPr>
-          <p:nvPr>
-            <p:ph type="body" sz="quarter" idx="3"/>
-          </p:nvPr>
-        </p:nvSpPr>
-        <p:spPr/>
-        <p:txBody>
-          <a:bodyPr/>
-          <a:lstStyle/>
-          <a:p>
-            <a:r>
-              <a:t>Unpaid sources with more than 10 thousand in closed revenue. Book rate = booked jobs divided by unique leads. Charleston GBP alone closed about 214 thousand from 636 unique leads, far ahead of Myrtle Beach GBP.</a:t>
-            </a:r>
-          </a:p>
-        </p:txBody>
-      </p:sp>
-      <p:sp>
-        <p:nvSpPr>
-          <p:cNvPr id="4" name="Slide Number Placeholder 3"/>
-          <p:cNvSpPr>
-            <a:spLocks noGrp="1"/>
-          </p:cNvSpPr>
-          <p:nvPr>
-            <p:ph type="sldNum" sz="quarter" idx="5"/>
-          </p:nvPr>
-        </p:nvSpPr>
-        <p:spPr/>
-      </p:sp>
-    </p:spTree>
-  </p:cSld>
-  <p:clrMapOvr>
-    <a:masterClrMapping/>
-  </p:clrMapOvr>
-</p:notes>
-</file>
-
-<file path=ppt/notesSlides/notesSlide12.xml><?xml version="1.0" encoding="utf-8"?>
-<p:notes xmlns:a="http://schemas.openxmlformats.org/drawingml/2006/main" xmlns:r="http://schemas.openxmlformats.org/officeDocument/2006/relationships" xmlns:p="http://schemas.openxmlformats.org/presentationml/2006/main">
-  <p:cSld>
-    <p:spTree>
-      <p:nvGrpSpPr>
-        <p:cNvPr id="1" name=""/>
-        <p:cNvGrpSpPr/>
-        <p:nvPr/>
-      </p:nvGrpSpPr>
-      <p:grpSpPr>
-        <a:xfrm>
-          <a:off x="0" y="0"/>
-          <a:ext cx="0" cy="0"/>
-          <a:chOff x="0" y="0"/>
-          <a:chExt cx="0" cy="0"/>
-        </a:xfrm>
-      </p:grpSpPr>
-      <p:sp>
-        <p:nvSpPr>
-          <p:cNvPr id="2" name="Slide Image Placeholder 1"/>
-          <p:cNvSpPr>
-            <a:spLocks noGrp="1" noRot="1" noChangeAspect="1"/>
-          </p:cNvSpPr>
-          <p:nvPr>
-            <p:ph type="sldImg" idx="2"/>
-          </p:nvPr>
-        </p:nvSpPr>
-        <p:spPr/>
-      </p:sp>
-      <p:sp>
-        <p:nvSpPr>
-          <p:cNvPr id="3" name="Notes Placeholder 2"/>
-          <p:cNvSpPr>
-            <a:spLocks noGrp="1"/>
-          </p:cNvSpPr>
-          <p:nvPr>
-            <p:ph type="body" sz="quarter" idx="3"/>
-          </p:nvPr>
-        </p:nvSpPr>
-        <p:spPr/>
-        <p:txBody>
-          <a:bodyPr/>
-          <a:lstStyle/>
-          <a:p>
-            <a:r>
-              <a:t>All campaigns with any activity, ranked by closed revenue. Direct Mktg = Direct Marketing; AI = Artificial Intelligence. Unique leads are counted per campaign, so a person who came through two campaigns appears in both.</a:t>
-            </a:r>
-          </a:p>
-        </p:txBody>
-      </p:sp>
-      <p:sp>
-        <p:nvSpPr>
-          <p:cNvPr id="4" name="Slide Number Placeholder 3"/>
-          <p:cNvSpPr>
-            <a:spLocks noGrp="1"/>
-          </p:cNvSpPr>
-          <p:nvPr>
-            <p:ph type="sldNum" sz="quarter" idx="5"/>
-          </p:nvPr>
-        </p:nvSpPr>
-        <p:spPr/>
-      </p:sp>
-    </p:spTree>
-  </p:cSld>
-  <p:clrMapOvr>
-    <a:masterClrMapping/>
-  </p:clrMapOvr>
-</p:notes>
-</file>
-
-<file path=ppt/notesSlides/notesSlide13.xml><?xml version="1.0" encoding="utf-8"?>
-<p:notes xmlns:a="http://schemas.openxmlformats.org/drawingml/2006/main" xmlns:r="http://schemas.openxmlformats.org/officeDocument/2006/relationships" xmlns:p="http://schemas.openxmlformats.org/presentationml/2006/main">
-  <p:cSld>
-    <p:spTree>
-      <p:nvGrpSpPr>
-        <p:cNvPr id="1" name=""/>
-        <p:cNvGrpSpPr/>
-        <p:nvPr/>
-      </p:nvGrpSpPr>
-      <p:grpSpPr>
-        <a:xfrm>
-          <a:off x="0" y="0"/>
-          <a:ext cx="0" cy="0"/>
-          <a:chOff x="0" y="0"/>
-          <a:chExt cx="0" cy="0"/>
-        </a:xfrm>
-      </p:grpSpPr>
-      <p:sp>
-        <p:nvSpPr>
-          <p:cNvPr id="2" name="Slide Image Placeholder 1"/>
-          <p:cNvSpPr>
-            <a:spLocks noGrp="1" noRot="1" noChangeAspect="1"/>
-          </p:cNvSpPr>
-          <p:nvPr>
-            <p:ph type="sldImg" idx="2"/>
-          </p:nvPr>
-        </p:nvSpPr>
-        <p:spPr/>
-      </p:sp>
-      <p:sp>
-        <p:nvSpPr>
-          <p:cNvPr id="3" name="Notes Placeholder 2"/>
-          <p:cNvSpPr>
-            <a:spLocks noGrp="1"/>
-          </p:cNvSpPr>
-          <p:nvPr>
-            <p:ph type="body" sz="quarter" idx="3"/>
-          </p:nvPr>
-        </p:nvSpPr>
-        <p:spPr/>
-        <p:txBody>
-          <a:bodyPr/>
-          <a:lstStyle/>
-          <a:p>
-            <a:r>
-              <a:t>All campaigns with any activity, ranked by closed revenue. Direct Mktg = Direct Marketing; AI = Artificial Intelligence. Unique leads are counted per campaign, so a person who came through two campaigns appears in both.</a:t>
-            </a:r>
-          </a:p>
-        </p:txBody>
-      </p:sp>
-      <p:sp>
-        <p:nvSpPr>
-          <p:cNvPr id="4" name="Slide Number Placeholder 3"/>
-          <p:cNvSpPr>
-            <a:spLocks noGrp="1"/>
-          </p:cNvSpPr>
-          <p:nvPr>
-            <p:ph type="sldNum" sz="quarter" idx="5"/>
-          </p:nvPr>
-        </p:nvSpPr>
-        <p:spPr/>
-      </p:sp>
-    </p:spTree>
-  </p:cSld>
-  <p:clrMapOvr>
-    <a:masterClrMapping/>
-  </p:clrMapOvr>
-</p:notes>
-</file>
-
-<file path=ppt/notesSlides/notesSlide14.xml><?xml version="1.0" encoding="utf-8"?>
-<p:notes xmlns:a="http://schemas.openxmlformats.org/drawingml/2006/main" xmlns:r="http://schemas.openxmlformats.org/officeDocument/2006/relationships" xmlns:p="http://schemas.openxmlformats.org/presentationml/2006/main">
-  <p:cSld>
-    <p:spTree>
-      <p:nvGrpSpPr>
-        <p:cNvPr id="1" name=""/>
-        <p:cNvGrpSpPr/>
-        <p:nvPr/>
-      </p:nvGrpSpPr>
-      <p:grpSpPr>
-        <a:xfrm>
-          <a:off x="0" y="0"/>
-          <a:ext cx="0" cy="0"/>
-          <a:chOff x="0" y="0"/>
-          <a:chExt cx="0" cy="0"/>
-        </a:xfrm>
-      </p:grpSpPr>
-      <p:sp>
-        <p:nvSpPr>
-          <p:cNvPr id="2" name="Slide Image Placeholder 1"/>
-          <p:cNvSpPr>
-            <a:spLocks noGrp="1" noRot="1" noChangeAspect="1"/>
-          </p:cNvSpPr>
-          <p:nvPr>
-            <p:ph type="sldImg" idx="2"/>
-          </p:nvPr>
-        </p:nvSpPr>
-        <p:spPr/>
-      </p:sp>
-      <p:sp>
-        <p:nvSpPr>
-          <p:cNvPr id="3" name="Notes Placeholder 2"/>
-          <p:cNvSpPr>
-            <a:spLocks noGrp="1"/>
-          </p:cNvSpPr>
-          <p:nvPr>
-            <p:ph type="body" sz="quarter" idx="3"/>
-          </p:nvPr>
-        </p:nvSpPr>
-        <p:spPr/>
-        <p:txBody>
-          <a:bodyPr/>
-          <a:lstStyle/>
-          <a:p>
-            <a:r>
-              <a:t>All campaigns with any activity, ranked by closed revenue. Direct Mktg = Direct Marketing; AI = Artificial Intelligence. Unique leads are counted per campaign, so a person who came through two campaigns appears in both.</a:t>
-            </a:r>
-          </a:p>
-        </p:txBody>
-      </p:sp>
-      <p:sp>
-        <p:nvSpPr>
-          <p:cNvPr id="4" name="Slide Number Placeholder 3"/>
-          <p:cNvSpPr>
-            <a:spLocks noGrp="1"/>
-          </p:cNvSpPr>
-          <p:nvPr>
-            <p:ph type="sldNum" sz="quarter" idx="5"/>
-          </p:nvPr>
-        </p:nvSpPr>
-        <p:spPr/>
-      </p:sp>
-    </p:spTree>
-  </p:cSld>
-  <p:clrMapOvr>
-    <a:masterClrMapping/>
-  </p:clrMapOvr>
-</p:notes>
-</file>
-
-<file path=ppt/notesSlides/notesSlide15.xml><?xml version="1.0" encoding="utf-8"?>
-<p:notes xmlns:a="http://schemas.openxmlformats.org/drawingml/2006/main" xmlns:r="http://schemas.openxmlformats.org/officeDocument/2006/relationships" xmlns:p="http://schemas.openxmlformats.org/presentationml/2006/main">
-  <p:cSld>
-    <p:spTree>
-      <p:nvGrpSpPr>
-        <p:cNvPr id="1" name=""/>
-        <p:cNvGrpSpPr/>
-        <p:nvPr/>
-      </p:nvGrpSpPr>
-      <p:grpSpPr>
-        <a:xfrm>
-          <a:off x="0" y="0"/>
-          <a:ext cx="0" cy="0"/>
-          <a:chOff x="0" y="0"/>
-          <a:chExt cx="0" cy="0"/>
-        </a:xfrm>
-      </p:grpSpPr>
-      <p:sp>
-        <p:nvSpPr>
-          <p:cNvPr id="2" name="Slide Image Placeholder 1"/>
-          <p:cNvSpPr>
-            <a:spLocks noGrp="1" noRot="1" noChangeAspect="1"/>
-          </p:cNvSpPr>
-          <p:nvPr>
-            <p:ph type="sldImg" idx="2"/>
-          </p:nvPr>
-        </p:nvSpPr>
-        <p:spPr/>
-      </p:sp>
-      <p:sp>
-        <p:nvSpPr>
-          <p:cNvPr id="3" name="Notes Placeholder 2"/>
-          <p:cNvSpPr>
-            <a:spLocks noGrp="1"/>
-          </p:cNvSpPr>
-          <p:nvPr>
-            <p:ph type="body" sz="quarter" idx="3"/>
-          </p:nvPr>
-        </p:nvSpPr>
-        <p:spPr/>
-        <p:txBody>
-          <a:bodyPr/>
-          <a:lstStyle/>
-          <a:p>
-            <a:r>
-              <a:t>All campaigns with any activity, ranked by closed revenue. Direct Mktg = Direct Marketing; AI = Artificial Intelligence. Unique leads are counted per campaign, so a person who came through two campaigns appears in both.</a:t>
-            </a:r>
-          </a:p>
-        </p:txBody>
-      </p:sp>
-      <p:sp>
-        <p:nvSpPr>
-          <p:cNvPr id="4" name="Slide Number Placeholder 3"/>
-          <p:cNvSpPr>
-            <a:spLocks noGrp="1"/>
-          </p:cNvSpPr>
-          <p:nvPr>
-            <p:ph type="sldNum" sz="quarter" idx="5"/>
-          </p:nvPr>
-        </p:nvSpPr>
-        <p:spPr/>
-      </p:sp>
-    </p:spTree>
-  </p:cSld>
-  <p:clrMapOvr>
-    <a:masterClrMapping/>
-  </p:clrMapOvr>
-</p:notes>
-</file>
-
-<file path=ppt/notesSlides/notesSlide2.xml><?xml version="1.0" encoding="utf-8"?>
-<p:notes xmlns:a="http://schemas.openxmlformats.org/drawingml/2006/main" xmlns:r="http://schemas.openxmlformats.org/officeDocument/2006/relationships" xmlns:p="http://schemas.openxmlformats.org/presentationml/2006/main">
-  <p:cSld>
-    <p:spTree>
-      <p:nvGrpSpPr>
-        <p:cNvPr id="1" name=""/>
-        <p:cNvGrpSpPr/>
-        <p:nvPr/>
-      </p:nvGrpSpPr>
-      <p:grpSpPr>
-        <a:xfrm>
-          <a:off x="0" y="0"/>
-          <a:ext cx="0" cy="0"/>
-          <a:chOff x="0" y="0"/>
-          <a:chExt cx="0" cy="0"/>
-        </a:xfrm>
-      </p:grpSpPr>
-      <p:sp>
-        <p:nvSpPr>
-          <p:cNvPr id="2" name="Slide Image Placeholder 1"/>
-          <p:cNvSpPr>
-            <a:spLocks noGrp="1" noRot="1" noChangeAspect="1"/>
-          </p:cNvSpPr>
-          <p:nvPr>
-            <p:ph type="sldImg" idx="2"/>
-          </p:nvPr>
-        </p:nvSpPr>
-        <p:spPr/>
-      </p:sp>
-      <p:sp>
-        <p:nvSpPr>
-          <p:cNvPr id="3" name="Notes Placeholder 2"/>
-          <p:cNvSpPr>
-            <a:spLocks noGrp="1"/>
-          </p:cNvSpPr>
-          <p:nvPr>
-            <p:ph type="body" sz="quarter" idx="3"/>
-          </p:nvPr>
-        </p:nvSpPr>
-        <p:spPr/>
-        <p:txBody>
-          <a:bodyPr/>
-          <a:lstStyle/>
-          <a:p>
-            <a:r>
-              <a:t>Digital closed revenue from the SearchLight export (Jan 1 – Oct 25, 2026) is $822,061. Brand-assisted revenue, $225,333, is an estimate of revenue from customers who first called the main line and later came back through the website, Google listings or ads (55 jobs traced in Searchlight data). LettrLabs direct mail adds $94,000 and Charleston marketing (ROI Marketing, April–September) adds $244,807, for a total of $1,386,201.</a:t>
-            </a:r>
-          </a:p>
-        </p:txBody>
-      </p:sp>
-      <p:sp>
-        <p:nvSpPr>
-          <p:cNvPr id="4" name="Slide Number Placeholder 3"/>
-          <p:cNvSpPr>
-            <a:spLocks noGrp="1"/>
-          </p:cNvSpPr>
-          <p:nvPr>
-            <p:ph type="sldNum" sz="quarter" idx="5"/>
-          </p:nvPr>
-        </p:nvSpPr>
-        <p:spPr/>
-      </p:sp>
-    </p:spTree>
-  </p:cSld>
-  <p:clrMapOvr>
-    <a:masterClrMapping/>
-  </p:clrMapOvr>
-</p:notes>
-</file>
-
-<file path=ppt/notesSlides/notesSlide3.xml><?xml version="1.0" encoding="utf-8"?>
-<p:notes xmlns:a="http://schemas.openxmlformats.org/drawingml/2006/main" xmlns:r="http://schemas.openxmlformats.org/officeDocument/2006/relationships" xmlns:p="http://schemas.openxmlformats.org/presentationml/2006/main">
-  <p:cSld>
-    <p:spTree>
-      <p:nvGrpSpPr>
-        <p:cNvPr id="1" name=""/>
-        <p:cNvGrpSpPr/>
-        <p:nvPr/>
-      </p:nvGrpSpPr>
-      <p:grpSpPr>
-        <a:xfrm>
-          <a:off x="0" y="0"/>
-          <a:ext cx="0" cy="0"/>
-          <a:chOff x="0" y="0"/>
-          <a:chExt cx="0" cy="0"/>
-        </a:xfrm>
-      </p:grpSpPr>
-      <p:sp>
-        <p:nvSpPr>
-          <p:cNvPr id="2" name="Slide Image Placeholder 1"/>
-          <p:cNvSpPr>
-            <a:spLocks noGrp="1" noRot="1" noChangeAspect="1"/>
-          </p:cNvSpPr>
-          <p:nvPr>
-            <p:ph type="sldImg" idx="2"/>
-          </p:nvPr>
-        </p:nvSpPr>
-        <p:spPr/>
-      </p:sp>
-      <p:sp>
-        <p:nvSpPr>
-          <p:cNvPr id="3" name="Notes Placeholder 2"/>
-          <p:cNvSpPr>
-            <a:spLocks noGrp="1"/>
-          </p:cNvSpPr>
-          <p:nvPr>
-            <p:ph type="body" sz="quarter" idx="3"/>
-          </p:nvPr>
-        </p:nvSpPr>
-        <p:spPr/>
-        <p:txBody>
-          <a:bodyPr/>
-          <a:lstStyle/>
-          <a:p>
-            <a:r>
-              <a:t>Closed revenue of 841 thousand on 174 thousand of ad spend. The 4.8x return counts revenue from every channel against ad spend; paid advertising on its own returned about 2x. The brand-assisted figure is an estimate explained on slide 4.</a:t>
-            </a:r>
-          </a:p>
-        </p:txBody>
-      </p:sp>
-      <p:sp>
-        <p:nvSpPr>
-          <p:cNvPr id="4" name="Slide Number Placeholder 3"/>
-          <p:cNvSpPr>
-            <a:spLocks noGrp="1"/>
-          </p:cNvSpPr>
-          <p:nvPr>
-            <p:ph type="sldNum" sz="quarter" idx="5"/>
-          </p:nvPr>
-        </p:nvSpPr>
-        <p:spPr/>
-      </p:sp>
-    </p:spTree>
-  </p:cSld>
-  <p:clrMapOvr>
-    <a:masterClrMapping/>
-  </p:clrMapOvr>
-</p:notes>
-</file>
-
-<file path=ppt/notesSlides/notesSlide4.xml><?xml version="1.0" encoding="utf-8"?>
-<p:notes xmlns:a="http://schemas.openxmlformats.org/drawingml/2006/main" xmlns:r="http://schemas.openxmlformats.org/officeDocument/2006/relationships" xmlns:p="http://schemas.openxmlformats.org/presentationml/2006/main">
-  <p:cSld>
-    <p:spTree>
-      <p:nvGrpSpPr>
-        <p:cNvPr id="1" name=""/>
-        <p:cNvGrpSpPr/>
-        <p:nvPr/>
-      </p:nvGrpSpPr>
-      <p:grpSpPr>
-        <a:xfrm>
-          <a:off x="0" y="0"/>
-          <a:ext cx="0" cy="0"/>
-          <a:chOff x="0" y="0"/>
-          <a:chExt cx="0" cy="0"/>
-        </a:xfrm>
-      </p:grpSpPr>
-      <p:sp>
-        <p:nvSpPr>
-          <p:cNvPr id="2" name="Slide Image Placeholder 1"/>
-          <p:cNvSpPr>
-            <a:spLocks noGrp="1" noRot="1" noChangeAspect="1"/>
-          </p:cNvSpPr>
-          <p:nvPr>
-            <p:ph type="sldImg" idx="2"/>
-          </p:nvPr>
-        </p:nvSpPr>
-        <p:spPr/>
-      </p:sp>
-      <p:sp>
-        <p:nvSpPr>
-          <p:cNvPr id="3" name="Notes Placeholder 2"/>
-          <p:cNvSpPr>
-            <a:spLocks noGrp="1"/>
-          </p:cNvSpPr>
-          <p:nvPr>
-            <p:ph type="body" sz="quarter" idx="3"/>
-          </p:nvPr>
-        </p:nvSpPr>
-        <p:spPr/>
-        <p:txBody>
-          <a:bodyPr/>
-          <a:lstStyle/>
-          <a:p>
-            <a:r>
-              <a:t>Residential growth, January 1 to October 23, 2026: total Charleston and Myrtle Beach revenue of $5,228,176, of which $1,404,507 is company marketing revenue, a 27% marketing contribution. Figures were provided separately.</a:t>
-            </a:r>
-          </a:p>
-        </p:txBody>
-      </p:sp>
-      <p:sp>
-        <p:nvSpPr>
-          <p:cNvPr id="4" name="Slide Number Placeholder 3"/>
-          <p:cNvSpPr>
-            <a:spLocks noGrp="1"/>
-          </p:cNvSpPr>
-          <p:nvPr>
-            <p:ph type="sldNum" sz="quarter" idx="5"/>
-          </p:nvPr>
-        </p:nvSpPr>
-        <p:spPr/>
-      </p:sp>
-    </p:spTree>
-  </p:cSld>
-  <p:clrMapOvr>
-    <a:masterClrMapping/>
-  </p:clrMapOvr>
-</p:notes>
-</file>
-
-<file path=ppt/notesSlides/notesSlide5.xml><?xml version="1.0" encoding="utf-8"?>
-<p:notes xmlns:a="http://schemas.openxmlformats.org/drawingml/2006/main" xmlns:r="http://schemas.openxmlformats.org/officeDocument/2006/relationships" xmlns:p="http://schemas.openxmlformats.org/presentationml/2006/main">
-  <p:cSld>
-    <p:spTree>
-      <p:nvGrpSpPr>
-        <p:cNvPr id="1" name=""/>
-        <p:cNvGrpSpPr/>
-        <p:nvPr/>
-      </p:nvGrpSpPr>
-      <p:grpSpPr>
-        <a:xfrm>
-          <a:off x="0" y="0"/>
-          <a:ext cx="0" cy="0"/>
-          <a:chOff x="0" y="0"/>
-          <a:chExt cx="0" cy="0"/>
-        </a:xfrm>
-      </p:grpSpPr>
-      <p:sp>
-        <p:nvSpPr>
-          <p:cNvPr id="2" name="Slide Image Placeholder 1"/>
-          <p:cNvSpPr>
-            <a:spLocks noGrp="1" noRot="1" noChangeAspect="1"/>
-          </p:cNvSpPr>
-          <p:nvPr>
-            <p:ph type="sldImg" idx="2"/>
-          </p:nvPr>
-        </p:nvSpPr>
-        <p:spPr/>
-      </p:sp>
-      <p:sp>
-        <p:nvSpPr>
-          <p:cNvPr id="3" name="Notes Placeholder 2"/>
-          <p:cNvSpPr>
-            <a:spLocks noGrp="1"/>
-          </p:cNvSpPr>
-          <p:nvPr>
-            <p:ph type="body" sz="quarter" idx="3"/>
-          </p:nvPr>
-        </p:nvSpPr>
-        <p:spPr/>
-        <p:txBody>
-          <a:bodyPr/>
-          <a:lstStyle/>
-          <a:p>
-            <a:r>
-              <a:t>Charleston marketing managed by ROI Marketing, April through September 2026: $144,496 ad spend, 969 qualified leads at $149 per lead, 346 booked jobs and $244,807 in revenue. These figures were provided separately and are not from Searchlight.</a:t>
-            </a:r>
-          </a:p>
-        </p:txBody>
-      </p:sp>
-      <p:sp>
-        <p:nvSpPr>
-          <p:cNvPr id="4" name="Slide Number Placeholder 3"/>
-          <p:cNvSpPr>
-            <a:spLocks noGrp="1"/>
-          </p:cNvSpPr>
-          <p:nvPr>
-            <p:ph type="sldNum" sz="quarter" idx="5"/>
-          </p:nvPr>
-        </p:nvSpPr>
-        <p:spPr/>
-      </p:sp>
-    </p:spTree>
-  </p:cSld>
-  <p:clrMapOvr>
-    <a:masterClrMapping/>
-  </p:clrMapOvr>
-</p:notes>
-</file>
-
-<file path=ppt/notesSlides/notesSlide6.xml><?xml version="1.0" encoding="utf-8"?>
-<p:notes xmlns:a="http://schemas.openxmlformats.org/drawingml/2006/main" xmlns:r="http://schemas.openxmlformats.org/officeDocument/2006/relationships" xmlns:p="http://schemas.openxmlformats.org/presentationml/2006/main">
-  <p:cSld>
-    <p:spTree>
-      <p:nvGrpSpPr>
-        <p:cNvPr id="1" name=""/>
-        <p:cNvGrpSpPr/>
-        <p:nvPr/>
-      </p:nvGrpSpPr>
-      <p:grpSpPr>
-        <a:xfrm>
-          <a:off x="0" y="0"/>
-          <a:ext cx="0" cy="0"/>
-          <a:chOff x="0" y="0"/>
-          <a:chExt cx="0" cy="0"/>
-        </a:xfrm>
-      </p:grpSpPr>
-      <p:sp>
-        <p:nvSpPr>
-          <p:cNvPr id="2" name="Slide Image Placeholder 1"/>
-          <p:cNvSpPr>
-            <a:spLocks noGrp="1" noRot="1" noChangeAspect="1"/>
-          </p:cNvSpPr>
-          <p:nvPr>
-            <p:ph type="sldImg" idx="2"/>
-          </p:nvPr>
-        </p:nvSpPr>
-        <p:spPr/>
-      </p:sp>
-      <p:sp>
-        <p:nvSpPr>
-          <p:cNvPr id="3" name="Notes Placeholder 2"/>
-          <p:cNvSpPr>
-            <a:spLocks noGrp="1"/>
-          </p:cNvSpPr>
-          <p:nvPr>
-            <p:ph type="body" sz="quarter" idx="3"/>
-          </p:nvPr>
-        </p:nvSpPr>
-        <p:spPr/>
-        <p:txBody>
-          <a:bodyPr/>
-          <a:lstStyle/>
-          <a:p>
-            <a:r>
-              <a:t>CAP Marketing: $139,811 ad spend, 555 booked jobs and $650,259 in revenue. These figures were provided separately.</a:t>
-            </a:r>
-          </a:p>
-        </p:txBody>
-      </p:sp>
-      <p:sp>
-        <p:nvSpPr>
-          <p:cNvPr id="4" name="Slide Number Placeholder 3"/>
-          <p:cNvSpPr>
-            <a:spLocks noGrp="1"/>
-          </p:cNvSpPr>
-          <p:nvPr>
-            <p:ph type="sldNum" sz="quarter" idx="5"/>
-          </p:nvPr>
-        </p:nvSpPr>
-        <p:spPr/>
-      </p:sp>
-    </p:spTree>
-  </p:cSld>
-  <p:clrMapOvr>
-    <a:masterClrMapping/>
-  </p:clrMapOvr>
-</p:notes>
-</file>
-
-<file path=ppt/notesSlides/notesSlide7.xml><?xml version="1.0" encoding="utf-8"?>
-<p:notes xmlns:a="http://schemas.openxmlformats.org/drawingml/2006/main" xmlns:r="http://schemas.openxmlformats.org/officeDocument/2006/relationships" xmlns:p="http://schemas.openxmlformats.org/presentationml/2006/main">
-  <p:cSld>
-    <p:spTree>
-      <p:nvGrpSpPr>
-        <p:cNvPr id="1" name=""/>
-        <p:cNvGrpSpPr/>
-        <p:nvPr/>
-      </p:nvGrpSpPr>
-      <p:grpSpPr>
-        <a:xfrm>
-          <a:off x="0" y="0"/>
-          <a:ext cx="0" cy="0"/>
-          <a:chOff x="0" y="0"/>
-          <a:chExt cx="0" cy="0"/>
-        </a:xfrm>
-      </p:grpSpPr>
-      <p:sp>
-        <p:nvSpPr>
-          <p:cNvPr id="2" name="Slide Image Placeholder 1"/>
-          <p:cNvSpPr>
-            <a:spLocks noGrp="1" noRot="1" noChangeAspect="1"/>
-          </p:cNvSpPr>
-          <p:nvPr>
-            <p:ph type="sldImg" idx="2"/>
-          </p:nvPr>
-        </p:nvSpPr>
-        <p:spPr/>
-      </p:sp>
-      <p:sp>
-        <p:nvSpPr>
-          <p:cNvPr id="3" name="Notes Placeholder 2"/>
-          <p:cNvSpPr>
-            <a:spLocks noGrp="1"/>
-          </p:cNvSpPr>
-          <p:nvPr>
-            <p:ph type="body" sz="quarter" idx="3"/>
-          </p:nvPr>
-        </p:nvSpPr>
-        <p:spPr/>
-        <p:txBody>
-          <a:bodyPr/>
-          <a:lstStyle/>
-          <a:p>
-            <a:r>
-              <a:t>SearchLight export, Jan 1 – Oct 25, 2026. Total closed revenue $822,061 from 5,040 conversions and 3,631 unique leads on $177,204 of ad spend. Total ROAS of 4.64x counts closed revenue from every channel against ad spend; advertising on its own returned about 1.9x.</a:t>
-            </a:r>
-          </a:p>
-        </p:txBody>
-      </p:sp>
-      <p:sp>
-        <p:nvSpPr>
-          <p:cNvPr id="4" name="Slide Number Placeholder 3"/>
-          <p:cNvSpPr>
-            <a:spLocks noGrp="1"/>
-          </p:cNvSpPr>
-          <p:nvPr>
-            <p:ph type="sldNum" sz="quarter" idx="5"/>
-          </p:nvPr>
-        </p:nvSpPr>
-        <p:spPr/>
-      </p:sp>
-    </p:spTree>
-  </p:cSld>
-  <p:clrMapOvr>
-    <a:masterClrMapping/>
-  </p:clrMapOvr>
-</p:notes>
-</file>
-
-<file path=ppt/notesSlides/notesSlide8.xml><?xml version="1.0" encoding="utf-8"?>
-<p:notes xmlns:a="http://schemas.openxmlformats.org/drawingml/2006/main" xmlns:r="http://schemas.openxmlformats.org/officeDocument/2006/relationships" xmlns:p="http://schemas.openxmlformats.org/presentationml/2006/main">
-  <p:cSld>
-    <p:spTree>
-      <p:nvGrpSpPr>
-        <p:cNvPr id="1" name=""/>
-        <p:cNvGrpSpPr/>
-        <p:nvPr/>
-      </p:nvGrpSpPr>
-      <p:grpSpPr>
-        <a:xfrm>
-          <a:off x="0" y="0"/>
-          <a:ext cx="0" cy="0"/>
-          <a:chOff x="0" y="0"/>
-          <a:chExt cx="0" cy="0"/>
-        </a:xfrm>
-      </p:grpSpPr>
-      <p:sp>
-        <p:nvSpPr>
-          <p:cNvPr id="2" name="Slide Image Placeholder 1"/>
-          <p:cNvSpPr>
-            <a:spLocks noGrp="1" noRot="1" noChangeAspect="1"/>
-          </p:cNvSpPr>
-          <p:nvPr>
-            <p:ph type="sldImg" idx="2"/>
-          </p:nvPr>
-        </p:nvSpPr>
-        <p:spPr/>
-      </p:sp>
-      <p:sp>
-        <p:nvSpPr>
-          <p:cNvPr id="3" name="Notes Placeholder 2"/>
-          <p:cNvSpPr>
-            <a:spLocks noGrp="1"/>
-          </p:cNvSpPr>
-          <p:nvPr>
-            <p:ph type="body" sz="quarter" idx="3"/>
-          </p:nvPr>
-        </p:nvSpPr>
-        <p:spPr/>
-        <p:txBody>
-          <a:bodyPr/>
-          <a:lstStyle/>
-          <a:p>
-            <a:r>
-              <a:t>Tracked Searchlight revenue is $822,061 (Jan 1 – Oct 25). The brand-assisted estimate of $225,333 comes from a job-by-job trace of 55 jobs in Searchlight data: $105,953 came back through direct website visits, $55,789 through the website and other sources, $50,965 through organic (mostly Charleston GBP) and $12,626 through ads. It is not a Searchlight figure. Together they make $1,047,394 in marketing-influenced revenue.</a:t>
-            </a:r>
-          </a:p>
-        </p:txBody>
-      </p:sp>
-      <p:sp>
-        <p:nvSpPr>
-          <p:cNvPr id="4" name="Slide Number Placeholder 3"/>
-          <p:cNvSpPr>
-            <a:spLocks noGrp="1"/>
-          </p:cNvSpPr>
-          <p:nvPr>
-            <p:ph type="sldNum" sz="quarter" idx="5"/>
-          </p:nvPr>
-        </p:nvSpPr>
-        <p:spPr/>
-      </p:sp>
-    </p:spTree>
-  </p:cSld>
-  <p:clrMapOvr>
-    <a:masterClrMapping/>
-  </p:clrMapOvr>
-</p:notes>
-</file>
-
-<file path=ppt/notesSlides/notesSlide9.xml><?xml version="1.0" encoding="utf-8"?>
-<p:notes xmlns:a="http://schemas.openxmlformats.org/drawingml/2006/main" xmlns:r="http://schemas.openxmlformats.org/officeDocument/2006/relationships" xmlns:p="http://schemas.openxmlformats.org/presentationml/2006/main">
-  <p:cSld>
-    <p:spTree>
-      <p:nvGrpSpPr>
-        <p:cNvPr id="1" name=""/>
-        <p:cNvGrpSpPr/>
-        <p:nvPr/>
-      </p:nvGrpSpPr>
-      <p:grpSpPr>
-        <a:xfrm>
-          <a:off x="0" y="0"/>
-          <a:ext cx="0" cy="0"/>
-          <a:chOff x="0" y="0"/>
-          <a:chExt cx="0" cy="0"/>
-        </a:xfrm>
-      </p:grpSpPr>
-      <p:sp>
-        <p:nvSpPr>
-          <p:cNvPr id="2" name="Slide Image Placeholder 1"/>
-          <p:cNvSpPr>
-            <a:spLocks noGrp="1" noRot="1" noChangeAspect="1"/>
-          </p:cNvSpPr>
-          <p:nvPr>
-            <p:ph type="sldImg" idx="2"/>
-          </p:nvPr>
-        </p:nvSpPr>
-        <p:spPr/>
-      </p:sp>
-      <p:sp>
-        <p:nvSpPr>
-          <p:cNvPr id="3" name="Notes Placeholder 2"/>
-          <p:cNvSpPr>
-            <a:spLocks noGrp="1"/>
-          </p:cNvSpPr>
-          <p:nvPr>
-            <p:ph type="body" sz="quarter" idx="3"/>
-          </p:nvPr>
-        </p:nvSpPr>
-        <p:spPr/>
-        <p:txBody>
-          <a:bodyPr/>
-          <a:lstStyle/>
-          <a:p>
-            <a:r>
-              <a:t>Brand search and the plumbing Local Services Ads listing return around 9 to 11 dollars per dollar. The HVAC LSA listing and Carolina-Cool competitor search are lower but still return more than twice their cost.</a:t>
-            </a:r>
-          </a:p>
-        </p:txBody>
-      </p:sp>
-      <p:sp>
-        <p:nvSpPr>
-          <p:cNvPr id="4" name="Slide Number Placeholder 3"/>
-          <p:cNvSpPr>
-            <a:spLocks noGrp="1"/>
-          </p:cNvSpPr>
-          <p:nvPr>
-            <p:ph type="sldNum" sz="quarter" idx="5"/>
-          </p:nvPr>
-        </p:nvSpPr>
-        <p:spPr/>
-      </p:sp>
-    </p:spTree>
-  </p:cSld>
-  <p:clrMapOvr>
-    <a:masterClrMapping/>
-  </p:clrMapOvr>
-</p:notes>
 </file>
 
 <file path=ppt/slideLayouts/slideLayout1.xml><?xml version="1.0" encoding="utf-8"?>

</xml_diff>